<commit_message>
Slides: sessions 10 and 14; others in progress
Co-Authored-By: Claude Opus 5.5 <noreply@anthropic.com>
Claude-Session: https://claude.ai/code/session_01XkzKv8pUGMF9AsqSCMpnBq
</commit_message>
<xml_diff>
--- a/slides/decks/s06-transfusion-abo.pptx
+++ b/slides/decks/s06-transfusion-abo.pptx
@@ -134,19 +134,19 @@
   <p:extLst>
     <p:ext uri="{521415D9-36F7-43E2-AB2F-B90AF26B5E84}">
       <p14:sectionLst xmlns:p14="http://schemas.microsoft.com/office/powerpoint/2010/main">
-        <p14:section name="Opening" id="{7428a759-51ab-93e3-2d01-b168c312f85d}">
+        <p14:section name="Opening" id="{680e034a-d1e5-bcce-3577-53d232e74757}">
           <p14:sldIdLst>
             <p14:sldId id="256"/>
             <p14:sldId id="257"/>
           </p14:sldIdLst>
         </p14:section>
-        <p14:section name="Safe products" id="{d55343f2-7e5c-926e-1b7c-489942747076}">
+        <p14:section name="Safe products" id="{bfb23125-a588-3516-1c06-99398064c644}">
           <p14:sldIdLst>
             <p14:sldId id="258"/>
             <p14:sldId id="259"/>
           </p14:sldIdLst>
         </p14:section>
-        <p14:section name="Red cells and platelets" id="{32d225d2-2558-0437-9da7-20016e49df80}">
+        <p14:section name="Red cells and platelets" id="{7ec79790-ebb9-7155-8084-ded657af89e4}">
           <p14:sldIdLst>
             <p14:sldId id="260"/>
             <p14:sldId id="261"/>
@@ -154,7 +154,7 @@
             <p14:sldId id="263"/>
           </p14:sldIdLst>
         </p14:section>
-        <p14:section name="ABO-incompatible HCT" id="{98b93c85-a694-5e40-281d-3e1ef4020c2f}">
+        <p14:section name="ABO-incompatible HCT" id="{f631fddc-d7af-b895-9b12-78942eb7c583}">
           <p14:sldIdLst>
             <p14:sldId id="264"/>
             <p14:sldId id="265"/>
@@ -165,12 +165,12 @@
             <p14:sldId id="270"/>
           </p14:sldIdLst>
         </p14:section>
-        <p14:section name="Granulocytes" id="{5c31d5fd-0907-748a-0913-8bcb8728bbd0}">
+        <p14:section name="Granulocytes" id="{c8c88a56-e4da-2ec6-33b7-8878b581d3aa}">
           <p14:sldIdLst>
             <p14:sldId id="271"/>
           </p14:sldIdLst>
         </p14:section>
-        <p14:section name="Board questions" id="{6b88044f-fceb-8604-5fd3-42f4239c70ed}">
+        <p14:section name="Board questions" id="{28761598-07bc-9631-b5ab-095bf3f6c322}">
           <p14:sldIdLst>
             <p14:sldId id="272"/>
             <p14:sldId id="273"/>
@@ -180,14 +180,14 @@
             <p14:sldId id="277"/>
           </p14:sldIdLst>
         </p14:section>
-        <p14:section name="References" id="{fc69d633-31fd-16a7-0293-5e9543422559}">
+        <p14:section name="References" id="{11027263-6ef1-4944-0788-73721e274a4b}">
           <p14:sldIdLst>
             <p14:sldId id="278"/>
             <p14:sldId id="279"/>
             <p14:sldId id="280"/>
           </p14:sldIdLst>
         </p14:section>
-        <p14:section name="Backup" id="{c9945459-9c36-330d-f822-524c99626317}">
+        <p14:section name="Backup" id="{7ca3bec1-81ad-1c0e-b349-658ca57cf78f}">
           <p14:sldIdLst>
             <p14:sldId id="281"/>
             <p14:sldId id="282"/>
@@ -16996,7 +16996,7 @@
                   <a:schemeClr val="tx1"/>
                 </a:solidFill>
               </a:rPr>
-              <a:t>BACKUP · BACKUP · PLATELET REFRACTORINESS</a:t>
+              <a:t>BACKUP · PLATELET REFRACTORINESS</a:t>
             </a:r>
             <a:endParaRPr lang="en-US" sz="1100" dirty="0"/>
           </a:p>
@@ -17240,7 +17240,7 @@
                   <a:schemeClr val="tx1"/>
                 </a:solidFill>
               </a:rPr>
-              <a:t>BACKUP · BACKUP · HLA-MATCHED PLATELETS</a:t>
+              <a:t>BACKUP · HLA-MATCHED PLATELETS</a:t>
             </a:r>
             <a:endParaRPr lang="en-US" sz="1100" dirty="0"/>
           </a:p>
@@ -17661,7 +17661,7 @@
                             <a:schemeClr val="tx1"/>
                           </a:solidFill>
                         </a:rPr>
-                        <a:t>20 kg, Hb 6 → 9: 3 × 4 × 20 = 240 mL (speaker's arithmetic)</a:t>
+                        <a:t>Permissive mismatch: cross-reactive groups, epitopes</a:t>
                       </a:r>
                       <a:endParaRPr lang="en-US" sz="1600" dirty="0"/>
                     </a:p>
@@ -17743,7 +17743,7 @@
                             <a:schemeClr val="tx1"/>
                           </a:solidFill>
                         </a:rPr>
-                        <a:t>Liver iron not a strong OS factor (Armand 2014)</a:t>
+                        <a:t>Antigen-negative for the recipient's HLA antibodies</a:t>
                       </a:r>
                       <a:endParaRPr lang="en-US" sz="1600" dirty="0"/>
                     </a:p>
@@ -17825,7 +17825,7 @@
                             <a:schemeClr val="tx1"/>
                           </a:solidFill>
                         </a:rPr>
-                        <a:t>HPA antibodies if refractoriness persists and non-immune causes unlikely</a:t>
+                        <a:t>HPA antibodies if still refractory, non-immune unlikely</a:t>
                       </a:r>
                       <a:endParaRPr lang="en-US" sz="1600" dirty="0"/>
                     </a:p>
@@ -17907,7 +17907,7 @@
                             <a:schemeClr val="tx1"/>
                           </a:solidFill>
                         </a:rPr>
-                        <a:t>Autologous cryopreserved PC, rituximab, high-dose IVIg, plasmapheresis</a:t>
+                        <a:t>Autologous frozen PC, rituximab, IVIg, plasmapheresis</a:t>
                       </a:r>
                       <a:endParaRPr lang="en-US" sz="1600" dirty="0"/>
                     </a:p>
@@ -18076,7 +18076,7 @@
                   <a:schemeClr val="tx1"/>
                 </a:solidFill>
               </a:rPr>
-              <a:t>BACKUP · BACKUP · RED CELL DOSE AND IRON</a:t>
+              <a:t>BACKUP · RED CELL DOSE AND IRON</a:t>
             </a:r>
             <a:endParaRPr lang="en-US" sz="1100" dirty="0"/>
           </a:p>
@@ -18497,7 +18497,7 @@
                             <a:schemeClr val="tx1"/>
                           </a:solidFill>
                         </a:rPr>
-                        <a:t>20 kg, Hb 6 → 9 g/dL: 3 × 4 × 20 = 240 mL (speaker's arithmetic)</a:t>
+                        <a:t>20 kg, Hb 6 → 9: 3 × 4 × 20 = 240 mL (speaker's arithmetic)</a:t>
                       </a:r>
                       <a:endParaRPr lang="en-US" sz="1600" dirty="0"/>
                     </a:p>
@@ -18579,7 +18579,7 @@
                             <a:schemeClr val="tx1"/>
                           </a:solidFill>
                         </a:rPr>
-                        <a:t>Liver iron not a strong OS factor (Armand 2014 meta-analysis)</a:t>
+                        <a:t>Liver iron not a strong OS factor (Armand 2014)</a:t>
                       </a:r>
                       <a:endParaRPr lang="en-US" sz="1600" dirty="0"/>
                     </a:p>
@@ -18892,16 +18892,16 @@
         </p:nvGraphicFramePr>
         <p:xfrm>
           <a:off x="685800" y="2240280"/>
-          <a:ext cx="10826496" cy="914400"/>
+          <a:ext cx="10817352" cy="914400"/>
         </p:xfrm>
         <a:graphic>
           <a:graphicData uri="http://schemas.openxmlformats.org/drawingml/2006/table">
             <a:tbl>
               <a:tblPr/>
               <a:tblGrid>
-                <a:gridCol w="2560320"/>
+                <a:gridCol w="2459736"/>
                 <a:gridCol w="4919472"/>
-                <a:gridCol w="3346704"/>
+                <a:gridCol w="3438144"/>
               </a:tblGrid>
               <a:tr h="0">
                 <a:tc>
@@ -19138,7 +19138,7 @@
                             <a:schemeClr val="tx1"/>
                           </a:solidFill>
                         </a:rPr>
-                        <a:t>Less FNHTR, HLA alloimmunisation, CMV</a:t>
+                        <a:t>Less FNHTR, alloimmunisation, CMV</a:t>
                       </a:r>
                       <a:endParaRPr lang="en-US" sz="1500" dirty="0"/>
                     </a:p>
@@ -22634,7 +22634,7 @@
                   <a:schemeClr val="tx1"/>
                 </a:solidFill>
               </a:rPr>
-              <a:t>Prophylaxis stays standard in allo-HCT</a:t>
+              <a:t>Allo-HCT: still prophylactic</a:t>
             </a:r>
             <a:endParaRPr lang="en-US" sz="1500" dirty="0"/>
           </a:p>
@@ -23216,7 +23216,7 @@
                             <a:schemeClr val="tx1"/>
                           </a:solidFill>
                         </a:rPr>
-                        <a:t>Therapeutic-only vs prophylactic PC, age ≥ 16</a:t>
+                        <a:t>Therapeutic-only vs prophylactic (≥ 16 y)</a:t>
                       </a:r>
                       <a:endParaRPr lang="en-US" sz="1500" dirty="0"/>
                     </a:p>
@@ -23744,7 +23744,7 @@
                             <a:schemeClr val="tx1"/>
                           </a:solidFill>
                         </a:rPr>
-                        <a:t>Equivalent; apheresis wins only with HLA/HPA Ab</a:t>
+                        <a:t>Equal; apheresis better only with HLA/HPA Ab</a:t>
                       </a:r>
                       <a:endParaRPr lang="en-US" sz="1500" dirty="0"/>
                     </a:p>
@@ -23783,7 +23783,7 @@
         </p:nvSpPr>
         <p:spPr>
           <a:xfrm>
-            <a:off x="685800" y="4754880"/>
+            <a:off x="685800" y="5257800"/>
             <a:ext cx="10817352" cy="411480"/>
           </a:xfrm>
           <a:prstGeom prst="rect">
@@ -24665,7 +24665,7 @@
                   <a:schemeClr val="tx1"/>
                 </a:solidFill>
               </a:rPr>
-              <a:t>Major</a:t>
+              <a:t>Major: patient's Ab</a:t>
             </a:r>
             <a:endParaRPr lang="en-US" sz="1400" dirty="0"/>
           </a:p>
@@ -24707,7 +24707,7 @@
                   <a:schemeClr val="tx1"/>
                 </a:solidFill>
               </a:rPr>
-              <a:t>Patient O, donor A: patient's anti-A</a:t>
+              <a:t>Patient O, donor A</a:t>
             </a:r>
             <a:endParaRPr lang="en-US" sz="1600" dirty="0"/>
           </a:p>
@@ -24835,7 +24835,7 @@
                   <a:schemeClr val="tx1"/>
                 </a:solidFill>
               </a:rPr>
-              <a:t>Minor</a:t>
+              <a:t>Minor: donor's Ab</a:t>
             </a:r>
             <a:endParaRPr lang="en-US" sz="1400" dirty="0"/>
           </a:p>
@@ -24877,7 +24877,7 @@
                   <a:schemeClr val="tx1"/>
                 </a:solidFill>
               </a:rPr>
-              <a:t>Patient A, donor O: donor's anti-A</a:t>
+              <a:t>Patient A, donor O</a:t>
             </a:r>
             <a:endParaRPr lang="en-US" sz="1600" dirty="0"/>
           </a:p>
@@ -24943,7 +24943,7 @@
                   <a:schemeClr val="tx1"/>
                 </a:solidFill>
               </a:rPr>
-              <a:t>Delayed haemolysis by donor B cells</a:t>
+              <a:t>Haemolysis from donor B lymphocytes</a:t>
             </a:r>
             <a:endParaRPr lang="en-US" sz="1500" dirty="0"/>
           </a:p>
@@ -25005,7 +25005,7 @@
                   <a:schemeClr val="tx1"/>
                 </a:solidFill>
               </a:rPr>
-              <a:t>Bidirectional</a:t>
+              <a:t>Bidirectional: both</a:t>
             </a:r>
             <a:endParaRPr lang="en-US" sz="1400" dirty="0"/>
           </a:p>
@@ -25047,7 +25047,7 @@
                   <a:schemeClr val="tx1"/>
                 </a:solidFill>
               </a:rPr>
-              <a:t>Patient A, donor B: both directions</a:t>
+              <a:t>Patient A, donor B</a:t>
             </a:r>
             <a:endParaRPr lang="en-US" sz="1600" dirty="0"/>
           </a:p>

</xml_diff>

<commit_message>
Slides: session 16 neurological; others in progress
Co-Authored-By: Claude Opus 5.5 <noreply@anthropic.com>
Claude-Session: https://claude.ai/code/session_01XkzKv8pUGMF9AsqSCMpnBq
</commit_message>
<xml_diff>
--- a/slides/decks/s06-transfusion-abo.pptx
+++ b/slides/decks/s06-transfusion-abo.pptx
@@ -134,19 +134,19 @@
   <p:extLst>
     <p:ext uri="{521415D9-36F7-43E2-AB2F-B90AF26B5E84}">
       <p14:sectionLst xmlns:p14="http://schemas.microsoft.com/office/powerpoint/2010/main">
-        <p14:section name="Opening" id="{680e034a-d1e5-bcce-3577-53d232e74757}">
+        <p14:section name="Opening" id="{42fa5d08-cbb9-6205-841c-a1c0bcf105cc}">
           <p14:sldIdLst>
             <p14:sldId id="256"/>
             <p14:sldId id="257"/>
           </p14:sldIdLst>
         </p14:section>
-        <p14:section name="Safe products" id="{bfb23125-a588-3516-1c06-99398064c644}">
+        <p14:section name="Safe products" id="{0024c90e-fefd-f110-968c-a795fc23131e}">
           <p14:sldIdLst>
             <p14:sldId id="258"/>
             <p14:sldId id="259"/>
           </p14:sldIdLst>
         </p14:section>
-        <p14:section name="Red cells and platelets" id="{7ec79790-ebb9-7155-8084-ded657af89e4}">
+        <p14:section name="Red cells and platelets" id="{b8bc5f00-a5e5-5d93-bac9-12576a830aec}">
           <p14:sldIdLst>
             <p14:sldId id="260"/>
             <p14:sldId id="261"/>
@@ -154,7 +154,7 @@
             <p14:sldId id="263"/>
           </p14:sldIdLst>
         </p14:section>
-        <p14:section name="ABO-incompatible HCT" id="{f631fddc-d7af-b895-9b12-78942eb7c583}">
+        <p14:section name="ABO-incompatible HCT" id="{4cb28a8e-1a28-a530-0cc5-7591273f4246}">
           <p14:sldIdLst>
             <p14:sldId id="264"/>
             <p14:sldId id="265"/>
@@ -165,12 +165,12 @@
             <p14:sldId id="270"/>
           </p14:sldIdLst>
         </p14:section>
-        <p14:section name="Granulocytes" id="{c8c88a56-e4da-2ec6-33b7-8878b581d3aa}">
+        <p14:section name="Granulocytes" id="{f373621e-4d2b-f75a-c830-e0282254abcd}">
           <p14:sldIdLst>
             <p14:sldId id="271"/>
           </p14:sldIdLst>
         </p14:section>
-        <p14:section name="Board questions" id="{28761598-07bc-9631-b5ab-095bf3f6c322}">
+        <p14:section name="Board questions" id="{600c3706-64b8-7c7c-e98e-ebaea90cb412}">
           <p14:sldIdLst>
             <p14:sldId id="272"/>
             <p14:sldId id="273"/>
@@ -180,14 +180,14 @@
             <p14:sldId id="277"/>
           </p14:sldIdLst>
         </p14:section>
-        <p14:section name="References" id="{11027263-6ef1-4944-0788-73721e274a4b}">
+        <p14:section name="References" id="{e276d55f-ba85-8482-8d69-d080fff65463}">
           <p14:sldIdLst>
             <p14:sldId id="278"/>
             <p14:sldId id="279"/>
             <p14:sldId id="280"/>
           </p14:sldIdLst>
         </p14:section>
-        <p14:section name="Backup" id="{7ca3bec1-81ad-1c0e-b349-658ca57cf78f}">
+        <p14:section name="Backup" id="{bde3fb69-4aa4-5dd3-1722-8a8850306d79}">
           <p14:sldIdLst>
             <p14:sldId id="281"/>
             <p14:sldId id="282"/>
@@ -23378,7 +23378,7 @@
                             <a:schemeClr val="tx1"/>
                           </a:solidFill>
                         </a:rPr>
-                        <a:t>More bleeding in children, esp. auto-HCT</a:t>
+                        <a:t>More bleeding in children, mainly auto</a:t>
                       </a:r>
                       <a:endParaRPr lang="en-US" sz="1500" dirty="0"/>
                     </a:p>

</xml_diff>